<commit_message>
PTA presentation: add picnic photos
Co-Authored-By: Claude Sonnet 5.5 <noreply@anthropic.com>
Claude-Session: https://claude.ai/code/session_01NZxYRpYCJka2jQFTHvmGQ5
</commit_message>
<xml_diff>
--- a/PTA_Meeting_BCBS/BCBS_First_PTA_Meeting.pptx
+++ b/PTA_Meeting_BCBS/BCBS_First_PTA_Meeting.pptx
@@ -122,14 +122,14 @@
   <p:extLst>
     <p:ext uri="{521415D9-36F7-43E2-AB2F-B90AF26B5E84}">
       <p14:sectionLst xmlns:p14="http://schemas.microsoft.com/office/powerpoint/2010/main">
-        <p14:section name="Programme" id="{55324f93-3cde-670e-a5cf-f5afc21616a7}">
+        <p14:section name="Programme" id="{09f7de25-949c-acb8-1d80-d316b6185318}">
           <p14:sldIdLst>
             <p14:sldId id="256"/>
             <p14:sldId id="257"/>
             <p14:sldId id="258"/>
           </p14:sldIdLst>
         </p14:section>
-        <p14:section name="Rapport" id="{fe908ed2-5822-d19a-a545-319eda2e0896}">
+        <p14:section name="Rapport" id="{aae6fe55-076f-f96e-29fe-17b6654b5154}">
           <p14:sldIdLst>
             <p14:sldId id="259"/>
             <p14:sldId id="260"/>
@@ -137,14 +137,14 @@
             <p14:sldId id="262"/>
           </p14:sldIdLst>
         </p14:section>
-        <p14:section name="Vision et réalisations" id="{bf019418-6585-fbb0-4854-3d78b4f53eb9}">
+        <p14:section name="Vision et réalisations" id="{56fe9293-c369-869f-e93b-9f574618303b}">
           <p14:sldIdLst>
             <p14:sldId id="263"/>
             <p14:sldId id="264"/>
             <p14:sldId id="265"/>
           </p14:sldIdLst>
         </p14:section>
-        <p14:section name="Activités et clubs" id="{741e3230-f8b4-1e0a-bf73-3913f2508cf7}">
+        <p14:section name="Activités et clubs" id="{24663c87-eccc-e20a-7730-6735e9ebe28d}">
           <p14:sldIdLst>
             <p14:sldId id="266"/>
             <p14:sldId id="267"/>
@@ -4674,36 +4674,9 @@
           </a:p>
         </p:txBody>
       </p:sp>
-      <p:sp>
-        <p:nvSpPr>
-          <p:cNvPr id="9" name="IMAGE À AJOUTER – photo des enfants au pique-nique, Village Madiba"/>
-          <p:cNvSpPr/>
-          <p:nvPr/>
-        </p:nvSpPr>
-        <p:spPr>
-          <a:xfrm>
-            <a:off x="548640" y="3017520"/>
-            <a:ext cx="3611880" cy="3063240"/>
-          </a:xfrm>
-          <a:prstGeom prst="roundRect">
-            <a:avLst>
-              <a:gd name="adj" fmla="val 3582"/>
-            </a:avLst>
-          </a:prstGeom>
-          <a:solidFill>
-            <a:schemeClr val="bg2"/>
-          </a:solidFill>
-          <a:ln w="25400">
-            <a:solidFill>
-              <a:schemeClr val="accent1"/>
-            </a:solidFill>
-            <a:prstDash val="dash"/>
-          </a:ln>
-        </p:spPr>
-      </p:sp>
       <p:pic>
         <p:nvPicPr>
-          <p:cNvPr id="10" name="Icon image" descr="preencoded.png">    </p:cNvPr>
+          <p:cNvPr id="9" name="Photo pique-nique 1" descr="Les enfants et les enseignants au pique-nique, Village Madiba">    </p:cNvPr>
           <p:cNvPicPr>
             <a:picLocks noChangeAspect="1"/>
           </p:cNvPicPr>
@@ -4717,94 +4690,17 @@
         </p:blipFill>
         <p:spPr>
           <a:xfrm>
-            <a:off x="2103120" y="3936492"/>
-            <a:ext cx="502920" cy="502920"/>
+            <a:off x="548640" y="3017520"/>
+            <a:ext cx="2103120" cy="2807208"/>
           </a:xfrm>
           <a:prstGeom prst="rect">
             <a:avLst/>
           </a:prstGeom>
         </p:spPr>
       </p:pic>
-      <p:sp>
-        <p:nvSpPr>
-          <p:cNvPr id="11" name="Texte emplacement image"/>
-          <p:cNvSpPr txBox="1"/>
-          <p:nvPr/>
-        </p:nvSpPr>
-        <p:spPr>
-          <a:xfrm>
-            <a:off x="685800" y="4594860"/>
-            <a:ext cx="3337560" cy="1440180"/>
-          </a:xfrm>
-          <a:prstGeom prst="rect">
-            <a:avLst/>
-          </a:prstGeom>
-          <a:noFill/>
-          <a:ln/>
-        </p:spPr>
-        <p:txBody>
-          <a:bodyPr wrap="square" lIns="0" tIns="0" rIns="0" bIns="0" rtlCol="0" anchor="t"/>
-          <a:lstStyle/>
-          <a:p>
-            <a:pPr algn="ctr" indent="0" marL="0">
-              <a:buNone/>
-            </a:pPr>
-            <a:r>
-              <a:rPr lang="en-US" sz="1400" b="1" dirty="0">
-                <a:solidFill>
-                  <a:schemeClr val="accent1"/>
-                </a:solidFill>
-              </a:rPr>
-              <a:t>Insérer l’image ici / Insert image here</a:t>
-            </a:r>
-            <a:endParaRPr lang="en-US" sz="1400" dirty="0"/>
-          </a:p>
-          <a:p>
-            <a:pPr algn="ctr" indent="0" marL="0">
-              <a:buNone/>
-            </a:pPr>
-            <a:r>
-              <a:rPr lang="en-US" sz="1300" dirty="0">
-                <a:solidFill>
-                  <a:schemeClr val="accent6"/>
-                </a:solidFill>
-              </a:rPr>
-              <a:t>photo des enfants au pique-nique, Village Madiba</a:t>
-            </a:r>
-            <a:endParaRPr lang="en-US" sz="1400" dirty="0"/>
-          </a:p>
-        </p:txBody>
-      </p:sp>
-      <p:sp>
-        <p:nvSpPr>
-          <p:cNvPr id="12" name="IMAGE À AJOUTER – photo des enfants au pique-nique, Village Madiba"/>
-          <p:cNvSpPr/>
-          <p:nvPr/>
-        </p:nvSpPr>
-        <p:spPr>
-          <a:xfrm>
-            <a:off x="4297680" y="3017520"/>
-            <a:ext cx="3611880" cy="3063240"/>
-          </a:xfrm>
-          <a:prstGeom prst="roundRect">
-            <a:avLst>
-              <a:gd name="adj" fmla="val 3582"/>
-            </a:avLst>
-          </a:prstGeom>
-          <a:solidFill>
-            <a:schemeClr val="bg2"/>
-          </a:solidFill>
-          <a:ln w="25400">
-            <a:solidFill>
-              <a:schemeClr val="accent1"/>
-            </a:solidFill>
-            <a:prstDash val="dash"/>
-          </a:ln>
-        </p:spPr>
-      </p:sp>
       <p:pic>
         <p:nvPicPr>
-          <p:cNvPr id="13" name="Icon image" descr="preencoded.png">    </p:cNvPr>
+          <p:cNvPr id="10" name="Photo pique-nique 2" descr="Les enfants et les enseignants au pique-nique, Village Madiba">    </p:cNvPr>
           <p:cNvPicPr>
             <a:picLocks noChangeAspect="1"/>
           </p:cNvPicPr>
@@ -4818,94 +4714,17 @@
         </p:blipFill>
         <p:spPr>
           <a:xfrm>
-            <a:off x="5852160" y="3936492"/>
-            <a:ext cx="502920" cy="502920"/>
+            <a:off x="2798064" y="3017520"/>
+            <a:ext cx="2103120" cy="2807208"/>
           </a:xfrm>
           <a:prstGeom prst="rect">
             <a:avLst/>
           </a:prstGeom>
         </p:spPr>
       </p:pic>
-      <p:sp>
-        <p:nvSpPr>
-          <p:cNvPr id="14" name="Texte emplacement image"/>
-          <p:cNvSpPr txBox="1"/>
-          <p:nvPr/>
-        </p:nvSpPr>
-        <p:spPr>
-          <a:xfrm>
-            <a:off x="4434840" y="4594860"/>
-            <a:ext cx="3337560" cy="1440180"/>
-          </a:xfrm>
-          <a:prstGeom prst="rect">
-            <a:avLst/>
-          </a:prstGeom>
-          <a:noFill/>
-          <a:ln/>
-        </p:spPr>
-        <p:txBody>
-          <a:bodyPr wrap="square" lIns="0" tIns="0" rIns="0" bIns="0" rtlCol="0" anchor="t"/>
-          <a:lstStyle/>
-          <a:p>
-            <a:pPr algn="ctr" indent="0" marL="0">
-              <a:buNone/>
-            </a:pPr>
-            <a:r>
-              <a:rPr lang="en-US" sz="1400" b="1" dirty="0">
-                <a:solidFill>
-                  <a:schemeClr val="accent1"/>
-                </a:solidFill>
-              </a:rPr>
-              <a:t>Insérer l’image ici / Insert image here</a:t>
-            </a:r>
-            <a:endParaRPr lang="en-US" sz="1400" dirty="0"/>
-          </a:p>
-          <a:p>
-            <a:pPr algn="ctr" indent="0" marL="0">
-              <a:buNone/>
-            </a:pPr>
-            <a:r>
-              <a:rPr lang="en-US" sz="1300" dirty="0">
-                <a:solidFill>
-                  <a:schemeClr val="accent6"/>
-                </a:solidFill>
-              </a:rPr>
-              <a:t>photo des enfants au pique-nique, Village Madiba</a:t>
-            </a:r>
-            <a:endParaRPr lang="en-US" sz="1400" dirty="0"/>
-          </a:p>
-        </p:txBody>
-      </p:sp>
-      <p:sp>
-        <p:nvSpPr>
-          <p:cNvPr id="15" name="IMAGE À AJOUTER – photo des enfants au pique-nique, Village Madiba"/>
-          <p:cNvSpPr/>
-          <p:nvPr/>
-        </p:nvSpPr>
-        <p:spPr>
-          <a:xfrm>
-            <a:off x="8046720" y="3017520"/>
-            <a:ext cx="3611880" cy="3063240"/>
-          </a:xfrm>
-          <a:prstGeom prst="roundRect">
-            <a:avLst>
-              <a:gd name="adj" fmla="val 3582"/>
-            </a:avLst>
-          </a:prstGeom>
-          <a:solidFill>
-            <a:schemeClr val="bg2"/>
-          </a:solidFill>
-          <a:ln w="25400">
-            <a:solidFill>
-              <a:schemeClr val="accent1"/>
-            </a:solidFill>
-            <a:prstDash val="dash"/>
-          </a:ln>
-        </p:spPr>
-      </p:sp>
       <p:pic>
         <p:nvPicPr>
-          <p:cNvPr id="16" name="Icon image" descr="preencoded.png">    </p:cNvPr>
+          <p:cNvPr id="11" name="Photo pique-nique 3" descr="Les enfants et les enseignants au pique-nique, Village Madiba">    </p:cNvPr>
           <p:cNvPicPr>
             <a:picLocks noChangeAspect="1"/>
           </p:cNvPicPr>
@@ -4919,24 +4738,72 @@
         </p:blipFill>
         <p:spPr>
           <a:xfrm>
-            <a:off x="9601200" y="3936492"/>
-            <a:ext cx="502920" cy="502920"/>
+            <a:off x="5047488" y="3017520"/>
+            <a:ext cx="2103120" cy="2807208"/>
           </a:xfrm>
           <a:prstGeom prst="rect">
             <a:avLst/>
           </a:prstGeom>
         </p:spPr>
       </p:pic>
-      <p:sp>
-        <p:nvSpPr>
-          <p:cNvPr id="17" name="Texte emplacement image"/>
+      <p:pic>
+        <p:nvPicPr>
+          <p:cNvPr id="12" name="Photo pique-nique 4" descr="Les enfants et les enseignants au pique-nique, Village Madiba">    </p:cNvPr>
+          <p:cNvPicPr>
+            <a:picLocks noChangeAspect="1"/>
+          </p:cNvPicPr>
+          <p:nvPr/>
+        </p:nvPicPr>
+        <p:blipFill>
+          <a:blip r:embed="rId5"/>
+          <a:stretch>
+            <a:fillRect/>
+          </a:stretch>
+        </p:blipFill>
+        <p:spPr>
+          <a:xfrm>
+            <a:off x="7296912" y="3017520"/>
+            <a:ext cx="2103120" cy="2807208"/>
+          </a:xfrm>
+          <a:prstGeom prst="rect">
+            <a:avLst/>
+          </a:prstGeom>
+        </p:spPr>
+      </p:pic>
+      <p:pic>
+        <p:nvPicPr>
+          <p:cNvPr id="13" name="Photo pique-nique 5" descr="Les enfants et les enseignants au pique-nique, Village Madiba">    </p:cNvPr>
+          <p:cNvPicPr>
+            <a:picLocks noChangeAspect="1"/>
+          </p:cNvPicPr>
+          <p:nvPr/>
+        </p:nvPicPr>
+        <p:blipFill>
+          <a:blip r:embed="rId6"/>
+          <a:stretch>
+            <a:fillRect/>
+          </a:stretch>
+        </p:blipFill>
+        <p:spPr>
+          <a:xfrm>
+            <a:off x="9546336" y="3017520"/>
+            <a:ext cx="2103120" cy="2807208"/>
+          </a:xfrm>
+          <a:prstGeom prst="rect">
+            <a:avLst/>
+          </a:prstGeom>
+        </p:spPr>
+      </p:pic>
+      <p:sp>
+        <p:nvSpPr>
+          <p:cNvPr id="14" name="Légende"/>
           <p:cNvSpPr txBox="1"/>
           <p:nvPr/>
         </p:nvSpPr>
         <p:spPr>
           <a:xfrm>
-            <a:off x="8183880" y="4594860"/>
-            <a:ext cx="3337560" cy="1440180"/>
+            <a:off x="548640" y="5943600"/>
+            <a:ext cx="11109960" cy="365760"/>
           </a:xfrm>
           <a:prstGeom prst="rect">
             <a:avLst/>
@@ -4945,33 +4812,19 @@
           <a:ln/>
         </p:spPr>
         <p:txBody>
-          <a:bodyPr wrap="square" lIns="0" tIns="0" rIns="0" bIns="0" rtlCol="0" anchor="t"/>
+          <a:bodyPr wrap="square" lIns="0" tIns="0" rIns="0" bIns="0" rtlCol="0" anchor="ctr"/>
           <a:lstStyle/>
           <a:p>
-            <a:pPr algn="ctr" indent="0" marL="0">
-              <a:buNone/>
-            </a:pPr>
-            <a:r>
-              <a:rPr lang="en-US" sz="1400" b="1" dirty="0">
-                <a:solidFill>
-                  <a:schemeClr val="accent1"/>
-                </a:solidFill>
-              </a:rPr>
-              <a:t>Insérer l’image ici / Insert image here</a:t>
-            </a:r>
-            <a:endParaRPr lang="en-US" sz="1400" dirty="0"/>
-          </a:p>
-          <a:p>
-            <a:pPr algn="ctr" indent="0" marL="0">
-              <a:buNone/>
-            </a:pPr>
-            <a:r>
-              <a:rPr lang="en-US" sz="1300" dirty="0">
+            <a:pPr indent="0" marL="0">
+              <a:buNone/>
+            </a:pPr>
+            <a:r>
+              <a:rPr lang="en-US" sz="1400" dirty="0">
                 <a:solidFill>
                   <a:schemeClr val="accent6"/>
                 </a:solidFill>
               </a:rPr>
-              <a:t>photo des enfants au pique-nique, Village Madiba</a:t>
+              <a:t>Site de pique-nique, Village Madiba / Picnic site, Village Madiba</a:t>
             </a:r>
             <a:endParaRPr lang="en-US" sz="1400" dirty="0"/>
           </a:p>

</xml_diff>